<commit_message>
cambios en gazebo plugin
</commit_message>
<xml_diff>
--- a/2.Texto/Imag/gazebo_plugin.pptx
+++ b/2.Texto/Imag/gazebo_plugin.pptx
@@ -107,6 +107,11 @@
       </a:defRPr>
     </a:lvl9pPr>
   </p:defaultTextStyle>
+  <p:extLst>
+    <p:ext uri="{EFAFB233-063F-42B5-8137-9DF3F51BA10A}">
+      <p15:sldGuideLst xmlns:p15="http://schemas.microsoft.com/office/powerpoint/2012/main"/>
+    </p:ext>
+  </p:extLst>
 </p:presentation>
 </file>
 
@@ -192,7 +197,7 @@
           <a:p>
             <a:fld id="{F824E4E7-63B3-4264-B2A8-CF377920C2FE}" type="datetimeFigureOut">
               <a:rPr lang="en-US" smtClean="0"/>
-              <a:t>10/19/2025</a:t>
+              <a:t>5/16/2026</a:t>
             </a:fld>
             <a:endParaRPr lang="en-US"/>
           </a:p>
@@ -690,7 +695,7 @@
           <a:p>
             <a:fld id="{75C67C38-21E1-45C6-A293-08155DE0DF9E}" type="datetimeFigureOut">
               <a:rPr lang="en-US" smtClean="0"/>
-              <a:t>10/19/2025</a:t>
+              <a:t>5/16/2026</a:t>
             </a:fld>
             <a:endParaRPr lang="en-US"/>
           </a:p>
@@ -888,7 +893,7 @@
           <a:p>
             <a:fld id="{75C67C38-21E1-45C6-A293-08155DE0DF9E}" type="datetimeFigureOut">
               <a:rPr lang="en-US" smtClean="0"/>
-              <a:t>10/19/2025</a:t>
+              <a:t>5/16/2026</a:t>
             </a:fld>
             <a:endParaRPr lang="en-US"/>
           </a:p>
@@ -1096,7 +1101,7 @@
           <a:p>
             <a:fld id="{75C67C38-21E1-45C6-A293-08155DE0DF9E}" type="datetimeFigureOut">
               <a:rPr lang="en-US" smtClean="0"/>
-              <a:t>10/19/2025</a:t>
+              <a:t>5/16/2026</a:t>
             </a:fld>
             <a:endParaRPr lang="en-US"/>
           </a:p>
@@ -1294,7 +1299,7 @@
           <a:p>
             <a:fld id="{75C67C38-21E1-45C6-A293-08155DE0DF9E}" type="datetimeFigureOut">
               <a:rPr lang="en-US" smtClean="0"/>
-              <a:t>10/19/2025</a:t>
+              <a:t>5/16/2026</a:t>
             </a:fld>
             <a:endParaRPr lang="en-US"/>
           </a:p>
@@ -1569,7 +1574,7 @@
           <a:p>
             <a:fld id="{75C67C38-21E1-45C6-A293-08155DE0DF9E}" type="datetimeFigureOut">
               <a:rPr lang="en-US" smtClean="0"/>
-              <a:t>10/19/2025</a:t>
+              <a:t>5/16/2026</a:t>
             </a:fld>
             <a:endParaRPr lang="en-US"/>
           </a:p>
@@ -1834,7 +1839,7 @@
           <a:p>
             <a:fld id="{75C67C38-21E1-45C6-A293-08155DE0DF9E}" type="datetimeFigureOut">
               <a:rPr lang="en-US" smtClean="0"/>
-              <a:t>10/19/2025</a:t>
+              <a:t>5/16/2026</a:t>
             </a:fld>
             <a:endParaRPr lang="en-US"/>
           </a:p>
@@ -2246,7 +2251,7 @@
           <a:p>
             <a:fld id="{75C67C38-21E1-45C6-A293-08155DE0DF9E}" type="datetimeFigureOut">
               <a:rPr lang="en-US" smtClean="0"/>
-              <a:t>10/19/2025</a:t>
+              <a:t>5/16/2026</a:t>
             </a:fld>
             <a:endParaRPr lang="en-US"/>
           </a:p>
@@ -2387,7 +2392,7 @@
           <a:p>
             <a:fld id="{75C67C38-21E1-45C6-A293-08155DE0DF9E}" type="datetimeFigureOut">
               <a:rPr lang="en-US" smtClean="0"/>
-              <a:t>10/19/2025</a:t>
+              <a:t>5/16/2026</a:t>
             </a:fld>
             <a:endParaRPr lang="en-US"/>
           </a:p>
@@ -2500,7 +2505,7 @@
           <a:p>
             <a:fld id="{75C67C38-21E1-45C6-A293-08155DE0DF9E}" type="datetimeFigureOut">
               <a:rPr lang="en-US" smtClean="0"/>
-              <a:t>10/19/2025</a:t>
+              <a:t>5/16/2026</a:t>
             </a:fld>
             <a:endParaRPr lang="en-US"/>
           </a:p>
@@ -2811,7 +2816,7 @@
           <a:p>
             <a:fld id="{75C67C38-21E1-45C6-A293-08155DE0DF9E}" type="datetimeFigureOut">
               <a:rPr lang="en-US" smtClean="0"/>
-              <a:t>10/19/2025</a:t>
+              <a:t>5/16/2026</a:t>
             </a:fld>
             <a:endParaRPr lang="en-US"/>
           </a:p>
@@ -3099,7 +3104,7 @@
           <a:p>
             <a:fld id="{75C67C38-21E1-45C6-A293-08155DE0DF9E}" type="datetimeFigureOut">
               <a:rPr lang="en-US" smtClean="0"/>
-              <a:t>10/19/2025</a:t>
+              <a:t>5/16/2026</a:t>
             </a:fld>
             <a:endParaRPr lang="en-US"/>
           </a:p>
@@ -3340,7 +3345,7 @@
           <a:p>
             <a:fld id="{75C67C38-21E1-45C6-A293-08155DE0DF9E}" type="datetimeFigureOut">
               <a:rPr lang="en-US" smtClean="0"/>
-              <a:t>10/19/2025</a:t>
+              <a:t>5/16/2026</a:t>
             </a:fld>
             <a:endParaRPr lang="en-US"/>
           </a:p>
@@ -3771,8 +3776,8 @@
         </p:nvSpPr>
         <p:spPr>
           <a:xfrm>
-            <a:off x="4577915" y="2620479"/>
-            <a:ext cx="2615002" cy="535493"/>
+            <a:off x="4437300" y="1841361"/>
+            <a:ext cx="3317397" cy="929610"/>
           </a:xfrm>
           <a:prstGeom prst="roundRect">
             <a:avLst/>
@@ -3798,10 +3803,24 @@
           <a:p>
             <a:pPr algn="ctr"/>
             <a:r>
-              <a:rPr lang="es-ES" dirty="0"/>
-              <a:t>gazebo_ros_diff_drive</a:t>
-            </a:r>
-            <a:endParaRPr lang="en-US" dirty="0"/>
+              <a:rPr lang="en-US" b="1" dirty="0"/>
+              <a:t>libgazebo_ros_diff_drive.so</a:t>
+            </a:r>
+          </a:p>
+          <a:p>
+            <a:pPr algn="ctr"/>
+            <a:r>
+              <a:rPr lang="en-US" sz="1600" i="1" dirty="0"/>
+              <a:t>Plugin </a:t>
+            </a:r>
+            <a:r>
+              <a:rPr lang="en-US" sz="1600" i="1" dirty="0" err="1"/>
+              <a:t>diferencial</a:t>
+            </a:r>
+            <a:r>
+              <a:rPr lang="en-US" sz="1600" i="1" dirty="0"/>
+              <a:t> de Gazebo</a:t>
+            </a:r>
           </a:p>
         </p:txBody>
       </p:sp>
@@ -3819,8 +3838,8 @@
         </p:nvSpPr>
         <p:spPr>
           <a:xfrm>
-            <a:off x="463301" y="2620476"/>
-            <a:ext cx="1995949" cy="535493"/>
+            <a:off x="66713" y="1886813"/>
+            <a:ext cx="3290418" cy="848344"/>
           </a:xfrm>
           <a:prstGeom prst="parallelogram">
             <a:avLst/>
@@ -3846,14 +3865,26 @@
           <a:p>
             <a:pPr algn="ctr"/>
             <a:r>
-              <a:rPr lang="es-ES" dirty="0"/>
+              <a:rPr lang="es-ES" b="1" dirty="0"/>
               <a:t>/</a:t>
             </a:r>
             <a:r>
-              <a:rPr lang="es-ES" dirty="0" err="1"/>
+              <a:rPr lang="es-ES" b="1" dirty="0" err="1"/>
               <a:t>cmd_vel</a:t>
             </a:r>
-            <a:endParaRPr lang="en-US" dirty="0"/>
+            <a:endParaRPr lang="es-ES" b="1" dirty="0"/>
+          </a:p>
+          <a:p>
+            <a:pPr algn="ctr"/>
+            <a:r>
+              <a:rPr lang="es-ES" sz="1600" i="1" dirty="0" err="1"/>
+              <a:t>geometry_msgs</a:t>
+            </a:r>
+            <a:r>
+              <a:rPr lang="es-ES" sz="1600" i="1" dirty="0"/>
+              <a:t>/Twist</a:t>
+            </a:r>
+            <a:endParaRPr lang="en-US" sz="1600" i="1" dirty="0"/>
           </a:p>
         </p:txBody>
       </p:sp>
@@ -3871,8 +3902,8 @@
         </p:nvSpPr>
         <p:spPr>
           <a:xfrm>
-            <a:off x="4400934" y="5132620"/>
-            <a:ext cx="2978796" cy="535493"/>
+            <a:off x="4343279" y="5127613"/>
+            <a:ext cx="3956485" cy="929610"/>
           </a:xfrm>
           <a:prstGeom prst="roundRect">
             <a:avLst/>
@@ -3898,12 +3929,31 @@
           <a:p>
             <a:pPr algn="ctr"/>
             <a:r>
+              <a:rPr lang="es-ES" dirty="0"/>
+              <a:t>Motor de física Gazebo</a:t>
+            </a:r>
+          </a:p>
+          <a:p>
+            <a:pPr algn="ctr"/>
+            <a:r>
               <a:rPr lang="es-ES" dirty="0" err="1"/>
-              <a:t>Simulacion</a:t>
+              <a:t>left_wheel_joint</a:t>
             </a:r>
             <a:r>
               <a:rPr lang="es-ES" dirty="0"/>
-              <a:t> Robot</a:t>
+              <a:t>, </a:t>
+            </a:r>
+            <a:r>
+              <a:rPr lang="es-ES" dirty="0" err="1"/>
+              <a:t>right</a:t>
+            </a:r>
+            <a:r>
+              <a:rPr lang="es-ES" dirty="0"/>
+              <a:t> _</a:t>
+            </a:r>
+            <a:r>
+              <a:rPr lang="es-ES" dirty="0" err="1"/>
+              <a:t>wheel_joint</a:t>
             </a:r>
             <a:endParaRPr lang="en-US" dirty="0"/>
           </a:p>
@@ -3920,22 +3970,20 @@
           </p:cNvPr>
           <p:cNvCxnSpPr>
             <a:cxnSpLocks/>
-            <a:stCxn id="7" idx="1"/>
           </p:cNvCxnSpPr>
           <p:nvPr/>
         </p:nvCxnSpPr>
         <p:spPr>
-          <a:xfrm rot="10800000" flipH="1">
-            <a:off x="4400934" y="3155973"/>
-            <a:ext cx="717378" cy="2244395"/>
+          <a:xfrm rot="5400000" flipH="1" flipV="1">
+            <a:off x="4326927" y="3931385"/>
+            <a:ext cx="2392455" cy="1"/>
           </a:xfrm>
-          <a:prstGeom prst="bentConnector4">
+          <a:prstGeom prst="bentConnector3">
             <a:avLst>
-              <a:gd name="adj1" fmla="val -59278"/>
-              <a:gd name="adj2" fmla="val 55965"/>
+              <a:gd name="adj1" fmla="val 50000"/>
             </a:avLst>
           </a:prstGeom>
-          <a:ln w="57150">
+          <a:ln w="28575">
             <a:solidFill>
               <a:srgbClr val="002060"/>
             </a:solidFill>
@@ -3968,22 +4016,20 @@
           </p:cNvPr>
           <p:cNvCxnSpPr>
             <a:cxnSpLocks/>
-            <a:stCxn id="7" idx="3"/>
           </p:cNvCxnSpPr>
           <p:nvPr/>
         </p:nvCxnSpPr>
         <p:spPr>
-          <a:xfrm flipH="1" flipV="1">
-            <a:off x="6465333" y="3155972"/>
-            <a:ext cx="914397" cy="2244395"/>
+          <a:xfrm rot="5400000" flipH="1" flipV="1">
+            <a:off x="5479543" y="3952467"/>
+            <a:ext cx="2362993" cy="2"/>
           </a:xfrm>
-          <a:prstGeom prst="bentConnector4">
+          <a:prstGeom prst="bentConnector3">
             <a:avLst>
-              <a:gd name="adj1" fmla="val -63710"/>
-              <a:gd name="adj2" fmla="val 55965"/>
+              <a:gd name="adj1" fmla="val 50000"/>
             </a:avLst>
           </a:prstGeom>
-          <a:ln w="57150">
+          <a:ln w="28575">
             <a:solidFill>
               <a:srgbClr val="002060"/>
             </a:solidFill>
@@ -4020,7 +4066,7 @@
         </p:nvSpPr>
         <p:spPr>
           <a:xfrm>
-            <a:off x="9615344" y="2618020"/>
+            <a:off x="10158371" y="3650401"/>
             <a:ext cx="1486748" cy="535493"/>
           </a:xfrm>
           <a:prstGeom prst="roundRect">
@@ -4068,7 +4114,7 @@
         </p:nvSpPr>
         <p:spPr>
           <a:xfrm>
-            <a:off x="9615344" y="683524"/>
+            <a:off x="10152021" y="4761733"/>
             <a:ext cx="1486748" cy="535493"/>
           </a:xfrm>
           <a:prstGeom prst="roundRect">
@@ -4113,22 +4159,22 @@
           </p:cNvPr>
           <p:cNvCxnSpPr>
             <a:cxnSpLocks/>
-            <a:stCxn id="25" idx="0"/>
-            <a:endCxn id="26" idx="2"/>
+            <a:stCxn id="25" idx="2"/>
+            <a:endCxn id="26" idx="0"/>
           </p:cNvCxnSpPr>
           <p:nvPr/>
         </p:nvCxnSpPr>
         <p:spPr>
-          <a:xfrm rot="5400000" flipH="1" flipV="1">
-            <a:off x="9659217" y="1918519"/>
-            <a:ext cx="1399003" cy="12700"/>
+          <a:xfrm rot="5400000">
+            <a:off x="10610651" y="4470638"/>
+            <a:ext cx="575839" cy="6350"/>
           </a:xfrm>
           <a:prstGeom prst="bentConnector3">
             <a:avLst>
               <a:gd name="adj1" fmla="val 50000"/>
             </a:avLst>
           </a:prstGeom>
-          <a:ln w="57150">
+          <a:ln w="28575">
             <a:solidFill>
               <a:schemeClr val="accent5">
                 <a:lumMod val="50000"/>
@@ -4181,8 +4227,8 @@
         </p:blipFill>
         <p:spPr bwMode="auto">
           <a:xfrm>
-            <a:off x="3704250" y="1034910"/>
-            <a:ext cx="696683" cy="1000948"/>
+            <a:off x="3814667" y="956742"/>
+            <a:ext cx="647351" cy="930071"/>
           </a:xfrm>
           <a:prstGeom prst="rect">
             <a:avLst/>
@@ -4213,11 +4259,13 @@
         </p:nvSpPr>
         <p:spPr>
           <a:xfrm>
-            <a:off x="3269845" y="683524"/>
+            <a:off x="3495367" y="678517"/>
             <a:ext cx="5201265" cy="5638614"/>
           </a:xfrm>
           <a:prstGeom prst="roundRect">
-            <a:avLst/>
+            <a:avLst>
+              <a:gd name="adj" fmla="val 5136"/>
+            </a:avLst>
           </a:prstGeom>
           <a:noFill/>
           <a:ln w="76200">
@@ -4270,16 +4318,16 @@
           <p:nvPr/>
         </p:nvCxnSpPr>
         <p:spPr>
-          <a:xfrm>
-            <a:off x="2392313" y="2888223"/>
-            <a:ext cx="2185602" cy="3"/>
+          <a:xfrm flipV="1">
+            <a:off x="3251088" y="2306166"/>
+            <a:ext cx="1186212" cy="4819"/>
           </a:xfrm>
           <a:prstGeom prst="bentConnector3">
             <a:avLst>
               <a:gd name="adj1" fmla="val 50000"/>
             </a:avLst>
           </a:prstGeom>
-          <a:ln w="57150">
+          <a:ln w="28575">
             <a:solidFill>
               <a:srgbClr val="002060"/>
             </a:solidFill>
@@ -4318,16 +4366,16 @@
           <p:nvPr/>
         </p:nvCxnSpPr>
         <p:spPr>
-          <a:xfrm flipV="1">
-            <a:off x="7192917" y="2885767"/>
-            <a:ext cx="2422427" cy="2459"/>
+          <a:xfrm>
+            <a:off x="7754697" y="2306166"/>
+            <a:ext cx="2403674" cy="1611982"/>
           </a:xfrm>
           <a:prstGeom prst="bentConnector3">
             <a:avLst>
               <a:gd name="adj1" fmla="val 50000"/>
             </a:avLst>
           </a:prstGeom>
-          <a:ln w="57150">
+          <a:ln w="28575">
             <a:solidFill>
               <a:schemeClr val="accent5">
                 <a:lumMod val="50000"/>
@@ -4351,6 +4399,301 @@
           </a:fontRef>
         </p:style>
       </p:cxnSp>
+      <p:sp>
+        <p:nvSpPr>
+          <p:cNvPr id="30" name="TextBox 29">
+            <a:extLst>
+              <a:ext uri="{FF2B5EF4-FFF2-40B4-BE49-F238E27FC236}">
+                <a16:creationId xmlns:a16="http://schemas.microsoft.com/office/drawing/2014/main" id="{E67739C3-3CAC-0400-D406-ACD19FFC1DCB}"/>
+              </a:ext>
+            </a:extLst>
+          </p:cNvPr>
+          <p:cNvSpPr txBox="1"/>
+          <p:nvPr/>
+        </p:nvSpPr>
+        <p:spPr>
+          <a:xfrm>
+            <a:off x="3711944" y="3627188"/>
+            <a:ext cx="1708485" cy="523220"/>
+          </a:xfrm>
+          <a:prstGeom prst="rect">
+            <a:avLst/>
+          </a:prstGeom>
+          <a:noFill/>
+        </p:spPr>
+        <p:txBody>
+          <a:bodyPr wrap="square" rtlCol="0">
+            <a:spAutoFit/>
+          </a:bodyPr>
+          <a:lstStyle/>
+          <a:p>
+            <a:r>
+              <a:rPr lang="es-ES" sz="1400" i="1" dirty="0"/>
+              <a:t>Estado simulado de </a:t>
+            </a:r>
+            <a:r>
+              <a:rPr lang="es-ES" sz="1400" i="1" dirty="0" err="1"/>
+              <a:t>joints</a:t>
+            </a:r>
+            <a:endParaRPr lang="en-US" sz="1400" i="1" dirty="0"/>
+          </a:p>
+        </p:txBody>
+      </p:sp>
+      <p:sp>
+        <p:nvSpPr>
+          <p:cNvPr id="31" name="TextBox 30">
+            <a:extLst>
+              <a:ext uri="{FF2B5EF4-FFF2-40B4-BE49-F238E27FC236}">
+                <a16:creationId xmlns:a16="http://schemas.microsoft.com/office/drawing/2014/main" id="{02A17F89-0E7C-00D6-A921-E95C0806D124}"/>
+              </a:ext>
+            </a:extLst>
+          </p:cNvPr>
+          <p:cNvSpPr txBox="1"/>
+          <p:nvPr/>
+        </p:nvSpPr>
+        <p:spPr>
+          <a:xfrm>
+            <a:off x="6806940" y="3550244"/>
+            <a:ext cx="1668466" cy="738664"/>
+          </a:xfrm>
+          <a:prstGeom prst="rect">
+            <a:avLst/>
+          </a:prstGeom>
+          <a:noFill/>
+        </p:spPr>
+        <p:txBody>
+          <a:bodyPr wrap="square" rtlCol="0">
+            <a:spAutoFit/>
+          </a:bodyPr>
+          <a:lstStyle/>
+          <a:p>
+            <a:r>
+              <a:rPr lang="es-ES" sz="1400" i="1" dirty="0"/>
+              <a:t>Comandos de Velocidades de rueda</a:t>
+            </a:r>
+            <a:endParaRPr lang="en-US" sz="1400" i="1" dirty="0"/>
+          </a:p>
+        </p:txBody>
+      </p:sp>
+      <p:sp>
+        <p:nvSpPr>
+          <p:cNvPr id="43" name="Rectangle: Rounded Corners 42">
+            <a:extLst>
+              <a:ext uri="{FF2B5EF4-FFF2-40B4-BE49-F238E27FC236}">
+                <a16:creationId xmlns:a16="http://schemas.microsoft.com/office/drawing/2014/main" id="{3C4F8F1B-3394-9BB1-D723-6E15DC4449C4}"/>
+              </a:ext>
+            </a:extLst>
+          </p:cNvPr>
+          <p:cNvSpPr/>
+          <p:nvPr/>
+        </p:nvSpPr>
+        <p:spPr>
+          <a:xfrm>
+            <a:off x="9834515" y="2900517"/>
+            <a:ext cx="2077327" cy="2821858"/>
+          </a:xfrm>
+          <a:prstGeom prst="roundRect">
+            <a:avLst>
+              <a:gd name="adj" fmla="val 5136"/>
+            </a:avLst>
+          </a:prstGeom>
+          <a:noFill/>
+          <a:ln w="38100">
+            <a:solidFill>
+              <a:schemeClr val="bg1">
+                <a:lumMod val="50000"/>
+              </a:schemeClr>
+            </a:solidFill>
+            <a:prstDash val="dash"/>
+          </a:ln>
+        </p:spPr>
+        <p:style>
+          <a:lnRef idx="2">
+            <a:schemeClr val="accent1">
+              <a:shade val="15000"/>
+            </a:schemeClr>
+          </a:lnRef>
+          <a:fillRef idx="1">
+            <a:schemeClr val="accent1"/>
+          </a:fillRef>
+          <a:effectRef idx="0">
+            <a:schemeClr val="accent1"/>
+          </a:effectRef>
+          <a:fontRef idx="minor">
+            <a:schemeClr val="lt1"/>
+          </a:fontRef>
+        </p:style>
+        <p:txBody>
+          <a:bodyPr rtlCol="0" anchor="ctr"/>
+          <a:lstStyle/>
+          <a:p>
+            <a:pPr algn="ctr"/>
+            <a:endParaRPr lang="en-US"/>
+          </a:p>
+        </p:txBody>
+      </p:sp>
+      <p:sp>
+        <p:nvSpPr>
+          <p:cNvPr id="44" name="Rectangle: Rounded Corners 43">
+            <a:extLst>
+              <a:ext uri="{FF2B5EF4-FFF2-40B4-BE49-F238E27FC236}">
+                <a16:creationId xmlns:a16="http://schemas.microsoft.com/office/drawing/2014/main" id="{440D4E9C-819A-1F9A-6CD4-4FAA668C693C}"/>
+              </a:ext>
+            </a:extLst>
+          </p:cNvPr>
+          <p:cNvSpPr/>
+          <p:nvPr/>
+        </p:nvSpPr>
+        <p:spPr>
+          <a:xfrm>
+            <a:off x="9555753" y="1135626"/>
+            <a:ext cx="2516371" cy="781807"/>
+          </a:xfrm>
+          <a:prstGeom prst="roundRect">
+            <a:avLst/>
+          </a:prstGeom>
+        </p:spPr>
+        <p:style>
+          <a:lnRef idx="0">
+            <a:schemeClr val="accent5"/>
+          </a:lnRef>
+          <a:fillRef idx="3">
+            <a:schemeClr val="accent5"/>
+          </a:fillRef>
+          <a:effectRef idx="3">
+            <a:schemeClr val="accent5"/>
+          </a:effectRef>
+          <a:fontRef idx="minor">
+            <a:schemeClr val="lt1"/>
+          </a:fontRef>
+        </p:style>
+        <p:txBody>
+          <a:bodyPr rtlCol="0" anchor="ctr"/>
+          <a:lstStyle/>
+          <a:p>
+            <a:pPr algn="ctr"/>
+            <a:r>
+              <a:rPr lang="es-ES" dirty="0"/>
+              <a:t>/</a:t>
+            </a:r>
+            <a:r>
+              <a:rPr lang="es-ES" dirty="0" err="1"/>
+              <a:t>odom</a:t>
+            </a:r>
+            <a:endParaRPr lang="es-ES" dirty="0"/>
+          </a:p>
+          <a:p>
+            <a:pPr algn="ctr"/>
+            <a:r>
+              <a:rPr lang="es-ES" dirty="0" err="1"/>
+              <a:t>nav_msgs</a:t>
+            </a:r>
+            <a:r>
+              <a:rPr lang="es-ES" dirty="0"/>
+              <a:t>/</a:t>
+            </a:r>
+            <a:r>
+              <a:rPr lang="es-ES" dirty="0" err="1"/>
+              <a:t>Odometry</a:t>
+            </a:r>
+            <a:endParaRPr lang="en-US" dirty="0"/>
+          </a:p>
+        </p:txBody>
+      </p:sp>
+      <p:cxnSp>
+        <p:nvCxnSpPr>
+          <p:cNvPr id="45" name="Connector: Elbow 44">
+            <a:extLst>
+              <a:ext uri="{FF2B5EF4-FFF2-40B4-BE49-F238E27FC236}">
+                <a16:creationId xmlns:a16="http://schemas.microsoft.com/office/drawing/2014/main" id="{DE0C7EBD-4B49-DCFE-5897-417433FC70E9}"/>
+              </a:ext>
+            </a:extLst>
+          </p:cNvPr>
+          <p:cNvCxnSpPr>
+            <a:cxnSpLocks/>
+            <a:stCxn id="4" idx="3"/>
+            <a:endCxn id="44" idx="1"/>
+          </p:cNvCxnSpPr>
+          <p:nvPr/>
+        </p:nvCxnSpPr>
+        <p:spPr>
+          <a:xfrm flipV="1">
+            <a:off x="7754697" y="1526530"/>
+            <a:ext cx="1801056" cy="779636"/>
+          </a:xfrm>
+          <a:prstGeom prst="bentConnector3">
+            <a:avLst>
+              <a:gd name="adj1" fmla="val 50000"/>
+            </a:avLst>
+          </a:prstGeom>
+          <a:ln w="28575">
+            <a:solidFill>
+              <a:schemeClr val="accent5">
+                <a:lumMod val="50000"/>
+              </a:schemeClr>
+            </a:solidFill>
+            <a:tailEnd type="triangle"/>
+          </a:ln>
+        </p:spPr>
+        <p:style>
+          <a:lnRef idx="2">
+            <a:schemeClr val="accent1"/>
+          </a:lnRef>
+          <a:fillRef idx="0">
+            <a:schemeClr val="accent1"/>
+          </a:fillRef>
+          <a:effectRef idx="1">
+            <a:schemeClr val="accent1"/>
+          </a:effectRef>
+          <a:fontRef idx="minor">
+            <a:schemeClr val="tx1"/>
+          </a:fontRef>
+        </p:style>
+      </p:cxnSp>
+      <p:sp>
+        <p:nvSpPr>
+          <p:cNvPr id="55" name="TextBox 54">
+            <a:extLst>
+              <a:ext uri="{FF2B5EF4-FFF2-40B4-BE49-F238E27FC236}">
+                <a16:creationId xmlns:a16="http://schemas.microsoft.com/office/drawing/2014/main" id="{7D654A5F-A22F-E20E-5FAD-EC76597471E1}"/>
+              </a:ext>
+            </a:extLst>
+          </p:cNvPr>
+          <p:cNvSpPr txBox="1"/>
+          <p:nvPr/>
+        </p:nvSpPr>
+        <p:spPr>
+          <a:xfrm>
+            <a:off x="10013060" y="3074562"/>
+            <a:ext cx="1720236" cy="338554"/>
+          </a:xfrm>
+          <a:prstGeom prst="rect">
+            <a:avLst/>
+          </a:prstGeom>
+          <a:noFill/>
+        </p:spPr>
+        <p:txBody>
+          <a:bodyPr wrap="square">
+            <a:spAutoFit/>
+          </a:bodyPr>
+          <a:lstStyle/>
+          <a:p>
+            <a:r>
+              <a:rPr lang="es-ES" sz="1600" i="1" dirty="0" err="1"/>
+              <a:t>Difusion</a:t>
+            </a:r>
+            <a:r>
+              <a:rPr lang="es-ES" sz="1600" i="1" dirty="0"/>
+              <a:t> TF en /</a:t>
+            </a:r>
+            <a:r>
+              <a:rPr lang="es-ES" sz="1600" i="1" dirty="0" err="1"/>
+              <a:t>tf</a:t>
+            </a:r>
+            <a:endParaRPr lang="en-US" sz="1600" i="1" dirty="0"/>
+          </a:p>
+        </p:txBody>
+      </p:sp>
     </p:spTree>
     <p:extLst>
       <p:ext uri="{BB962C8B-B14F-4D97-AF65-F5344CB8AC3E}">

</xml_diff>